<commit_message>
preparação do slide 2
</commit_message>
<xml_diff>
--- a/slides/02_apresentacao_03-02/slide_02.pptx
+++ b/slides/02_apresentacao_03-02/slide_02.pptx
@@ -5,8 +5,10 @@
     <p:sldMasterId id="2147483648" r:id="rId1"/>
   </p:sldMasterIdLst>
   <p:sldIdLst>
-    <p:sldId id="256" r:id="rId2"/>
-    <p:sldId id="257" r:id="rId3"/>
+    <p:sldId id="259" r:id="rId2"/>
+    <p:sldId id="256" r:id="rId3"/>
+    <p:sldId id="257" r:id="rId4"/>
+    <p:sldId id="258" r:id="rId5"/>
   </p:sldIdLst>
   <p:sldSz cx="12192000" cy="6858000"/>
   <p:notesSz cx="6858000" cy="9144000"/>
@@ -262,7 +264,7 @@
           <a:p>
             <a:fld id="{52A158F4-354F-4B2E-A471-961B6743BD7D}" type="datetimeFigureOut">
               <a:rPr lang="en-US" smtClean="0"/>
-              <a:t>1/28/2026</a:t>
+              <a:t>1/29/2026</a:t>
             </a:fld>
             <a:endParaRPr lang="en-US"/>
           </a:p>
@@ -462,7 +464,7 @@
           <a:p>
             <a:fld id="{52A158F4-354F-4B2E-A471-961B6743BD7D}" type="datetimeFigureOut">
               <a:rPr lang="en-US" smtClean="0"/>
-              <a:t>1/28/2026</a:t>
+              <a:t>1/29/2026</a:t>
             </a:fld>
             <a:endParaRPr lang="en-US"/>
           </a:p>
@@ -672,7 +674,7 @@
           <a:p>
             <a:fld id="{52A158F4-354F-4B2E-A471-961B6743BD7D}" type="datetimeFigureOut">
               <a:rPr lang="en-US" smtClean="0"/>
-              <a:t>1/28/2026</a:t>
+              <a:t>1/29/2026</a:t>
             </a:fld>
             <a:endParaRPr lang="en-US"/>
           </a:p>
@@ -872,7 +874,7 @@
           <a:p>
             <a:fld id="{52A158F4-354F-4B2E-A471-961B6743BD7D}" type="datetimeFigureOut">
               <a:rPr lang="en-US" smtClean="0"/>
-              <a:t>1/28/2026</a:t>
+              <a:t>1/29/2026</a:t>
             </a:fld>
             <a:endParaRPr lang="en-US"/>
           </a:p>
@@ -1148,7 +1150,7 @@
           <a:p>
             <a:fld id="{52A158F4-354F-4B2E-A471-961B6743BD7D}" type="datetimeFigureOut">
               <a:rPr lang="en-US" smtClean="0"/>
-              <a:t>1/28/2026</a:t>
+              <a:t>1/29/2026</a:t>
             </a:fld>
             <a:endParaRPr lang="en-US"/>
           </a:p>
@@ -1416,7 +1418,7 @@
           <a:p>
             <a:fld id="{52A158F4-354F-4B2E-A471-961B6743BD7D}" type="datetimeFigureOut">
               <a:rPr lang="en-US" smtClean="0"/>
-              <a:t>1/28/2026</a:t>
+              <a:t>1/29/2026</a:t>
             </a:fld>
             <a:endParaRPr lang="en-US"/>
           </a:p>
@@ -1831,7 +1833,7 @@
           <a:p>
             <a:fld id="{52A158F4-354F-4B2E-A471-961B6743BD7D}" type="datetimeFigureOut">
               <a:rPr lang="en-US" smtClean="0"/>
-              <a:t>1/28/2026</a:t>
+              <a:t>1/29/2026</a:t>
             </a:fld>
             <a:endParaRPr lang="en-US"/>
           </a:p>
@@ -1973,7 +1975,7 @@
           <a:p>
             <a:fld id="{52A158F4-354F-4B2E-A471-961B6743BD7D}" type="datetimeFigureOut">
               <a:rPr lang="en-US" smtClean="0"/>
-              <a:t>1/28/2026</a:t>
+              <a:t>1/29/2026</a:t>
             </a:fld>
             <a:endParaRPr lang="en-US"/>
           </a:p>
@@ -2086,7 +2088,7 @@
           <a:p>
             <a:fld id="{52A158F4-354F-4B2E-A471-961B6743BD7D}" type="datetimeFigureOut">
               <a:rPr lang="en-US" smtClean="0"/>
-              <a:t>1/28/2026</a:t>
+              <a:t>1/29/2026</a:t>
             </a:fld>
             <a:endParaRPr lang="en-US"/>
           </a:p>
@@ -2399,7 +2401,7 @@
           <a:p>
             <a:fld id="{52A158F4-354F-4B2E-A471-961B6743BD7D}" type="datetimeFigureOut">
               <a:rPr lang="en-US" smtClean="0"/>
-              <a:t>1/28/2026</a:t>
+              <a:t>1/29/2026</a:t>
             </a:fld>
             <a:endParaRPr lang="en-US"/>
           </a:p>
@@ -2688,7 +2690,7 @@
           <a:p>
             <a:fld id="{52A158F4-354F-4B2E-A471-961B6743BD7D}" type="datetimeFigureOut">
               <a:rPr lang="en-US" smtClean="0"/>
-              <a:t>1/28/2026</a:t>
+              <a:t>1/29/2026</a:t>
             </a:fld>
             <a:endParaRPr lang="en-US"/>
           </a:p>
@@ -2765,9 +2767,18 @@
 <p:sldMaster xmlns:a="http://schemas.openxmlformats.org/drawingml/2006/main" xmlns:r="http://schemas.openxmlformats.org/officeDocument/2006/relationships" xmlns:p="http://schemas.openxmlformats.org/presentationml/2006/main">
   <p:cSld>
     <p:bg>
-      <p:bgRef idx="1001">
-        <a:schemeClr val="bg1"/>
-      </p:bgRef>
+      <p:bgPr>
+        <a:blipFill dpi="0" rotWithShape="1">
+          <a:blip r:embed="rId13">
+            <a:lum/>
+          </a:blip>
+          <a:srcRect/>
+          <a:stretch>
+            <a:fillRect/>
+          </a:stretch>
+        </a:blipFill>
+        <a:effectLst/>
+      </p:bgPr>
     </p:bg>
     <p:spTree>
       <p:nvGrpSpPr>
@@ -2931,7 +2942,7 @@
           <a:p>
             <a:fld id="{52A158F4-354F-4B2E-A471-961B6743BD7D}" type="datetimeFigureOut">
               <a:rPr lang="en-US" smtClean="0"/>
-              <a:t>1/28/2026</a:t>
+              <a:t>1/29/2026</a:t>
             </a:fld>
             <a:endParaRPr lang="en-US"/>
           </a:p>
@@ -3348,12 +3359,58 @@
           <a:chExt cx="0" cy="0"/>
         </a:xfrm>
       </p:grpSpPr>
+      <p:sp>
+        <p:nvSpPr>
+          <p:cNvPr id="6" name="Retângulo 5">
+            <a:extLst>
+              <a:ext uri="{FF2B5EF4-FFF2-40B4-BE49-F238E27FC236}">
+                <a16:creationId xmlns:a16="http://schemas.microsoft.com/office/drawing/2014/main" id="{5FB562E6-9877-8264-BABD-B03358E97971}"/>
+              </a:ext>
+            </a:extLst>
+          </p:cNvPr>
+          <p:cNvSpPr/>
+          <p:nvPr/>
+        </p:nvSpPr>
+        <p:spPr>
+          <a:xfrm>
+            <a:off x="-104775" y="-95250"/>
+            <a:ext cx="12401550" cy="6953250"/>
+          </a:xfrm>
+          <a:prstGeom prst="rect">
+            <a:avLst/>
+          </a:prstGeom>
+        </p:spPr>
+        <p:style>
+          <a:lnRef idx="2">
+            <a:schemeClr val="dk1">
+              <a:shade val="15000"/>
+            </a:schemeClr>
+          </a:lnRef>
+          <a:fillRef idx="1">
+            <a:schemeClr val="dk1"/>
+          </a:fillRef>
+          <a:effectRef idx="0">
+            <a:schemeClr val="dk1"/>
+          </a:effectRef>
+          <a:fontRef idx="minor">
+            <a:schemeClr val="lt1"/>
+          </a:fontRef>
+        </p:style>
+        <p:txBody>
+          <a:bodyPr rtlCol="0" anchor="ctr"/>
+          <a:lstStyle/>
+          <a:p>
+            <a:pPr algn="ctr"/>
+            <a:endParaRPr lang="en-US"/>
+          </a:p>
+        </p:txBody>
+      </p:sp>
       <p:pic>
         <p:nvPicPr>
-          <p:cNvPr id="6" name="Imagem 5">
-            <a:extLst>
-              <a:ext uri="{FF2B5EF4-FFF2-40B4-BE49-F238E27FC236}">
-                <a16:creationId xmlns:a16="http://schemas.microsoft.com/office/drawing/2014/main" id="{D10F10BF-B88E-B0B9-E593-70815F72469A}"/>
+          <p:cNvPr id="8" name="Imagem 7">
+            <a:extLst>
+              <a:ext uri="{FF2B5EF4-FFF2-40B4-BE49-F238E27FC236}">
+                <a16:creationId xmlns:a16="http://schemas.microsoft.com/office/drawing/2014/main" id="{F79FE40E-1361-3747-6077-8C2F91E67956}"/>
               </a:ext>
             </a:extLst>
           </p:cNvPr>
@@ -3376,8 +3433,8 @@
         </p:blipFill>
         <p:spPr>
           <a:xfrm>
-            <a:off x="-241489" y="-108203"/>
-            <a:ext cx="12674979" cy="7074407"/>
+            <a:off x="2959100" y="1664494"/>
+            <a:ext cx="6273801" cy="3529013"/>
           </a:xfrm>
           <a:prstGeom prst="rect">
             <a:avLst/>
@@ -3387,13 +3444,25 @@
     </p:spTree>
     <p:extLst>
       <p:ext uri="{BB962C8B-B14F-4D97-AF65-F5344CB8AC3E}">
-        <p14:creationId xmlns:p14="http://schemas.microsoft.com/office/powerpoint/2010/main" val="1654209032"/>
+        <p14:creationId xmlns:p14="http://schemas.microsoft.com/office/powerpoint/2010/main" val="268954775"/>
       </p:ext>
     </p:extLst>
   </p:cSld>
   <p:clrMapOvr>
     <a:masterClrMapping/>
   </p:clrMapOvr>
+  <mc:AlternateContent xmlns:mc="http://schemas.openxmlformats.org/markup-compatibility/2006" xmlns:p159="http://schemas.microsoft.com/office/powerpoint/2015/09/main">
+    <mc:Choice Requires="p159">
+      <p:transition xmlns:p14="http://schemas.microsoft.com/office/powerpoint/2010/main" spd="slow" p14:dur="2000" advTm="2000">
+        <p159:morph option="byObject"/>
+      </p:transition>
+    </mc:Choice>
+    <mc:Fallback xmlns="">
+      <p:transition spd="slow" advTm="2000">
+        <p:fade/>
+      </p:transition>
+    </mc:Fallback>
+  </mc:AlternateContent>
 </p:sld>
 </file>
 
@@ -3414,10 +3483,1024 @@
           <a:chExt cx="0" cy="0"/>
         </a:xfrm>
       </p:grpSpPr>
+      <p:sp>
+        <p:nvSpPr>
+          <p:cNvPr id="2" name="Retângulo 1">
+            <a:extLst>
+              <a:ext uri="{FF2B5EF4-FFF2-40B4-BE49-F238E27FC236}">
+                <a16:creationId xmlns:a16="http://schemas.microsoft.com/office/drawing/2014/main" id="{3F0AAE9F-3EBA-47F0-8B0D-471E4E8EA210}"/>
+              </a:ext>
+            </a:extLst>
+          </p:cNvPr>
+          <p:cNvSpPr/>
+          <p:nvPr/>
+        </p:nvSpPr>
+        <p:spPr>
+          <a:xfrm>
+            <a:off x="-104775" y="-95250"/>
+            <a:ext cx="12401550" cy="6953250"/>
+          </a:xfrm>
+          <a:prstGeom prst="rect">
+            <a:avLst/>
+          </a:prstGeom>
+        </p:spPr>
+        <p:style>
+          <a:lnRef idx="2">
+            <a:schemeClr val="dk1">
+              <a:shade val="15000"/>
+            </a:schemeClr>
+          </a:lnRef>
+          <a:fillRef idx="1">
+            <a:schemeClr val="dk1"/>
+          </a:fillRef>
+          <a:effectRef idx="0">
+            <a:schemeClr val="dk1"/>
+          </a:effectRef>
+          <a:fontRef idx="minor">
+            <a:schemeClr val="lt1"/>
+          </a:fontRef>
+        </p:style>
+        <p:txBody>
+          <a:bodyPr rtlCol="0" anchor="ctr"/>
+          <a:lstStyle/>
+          <a:p>
+            <a:pPr algn="ctr"/>
+            <a:endParaRPr lang="en-US"/>
+          </a:p>
+        </p:txBody>
+      </p:sp>
+      <p:pic>
+        <p:nvPicPr>
+          <p:cNvPr id="6" name="Imagem 5">
+            <a:extLst>
+              <a:ext uri="{FF2B5EF4-FFF2-40B4-BE49-F238E27FC236}">
+                <a16:creationId xmlns:a16="http://schemas.microsoft.com/office/drawing/2014/main" id="{D10F10BF-B88E-B0B9-E593-70815F72469A}"/>
+              </a:ext>
+            </a:extLst>
+          </p:cNvPr>
+          <p:cNvPicPr>
+            <a:picLocks noChangeAspect="1"/>
+          </p:cNvPicPr>
+          <p:nvPr/>
+        </p:nvPicPr>
+        <p:blipFill>
+          <a:blip r:embed="rId2" cstate="screen">
+            <a:extLst>
+              <a:ext uri="{28A0092B-C50C-407E-A947-70E740481C1C}">
+                <a14:useLocalDpi xmlns:a14="http://schemas.microsoft.com/office/drawing/2010/main"/>
+              </a:ext>
+            </a:extLst>
+          </a:blip>
+          <a:stretch>
+            <a:fillRect/>
+          </a:stretch>
+        </p:blipFill>
+        <p:spPr>
+          <a:xfrm>
+            <a:off x="908051" y="0"/>
+            <a:ext cx="10375899" cy="5791200"/>
+          </a:xfrm>
+          <a:prstGeom prst="rect">
+            <a:avLst/>
+          </a:prstGeom>
+        </p:spPr>
+      </p:pic>
+      <p:pic>
+        <p:nvPicPr>
+          <p:cNvPr id="4" name="Imagem 3">
+            <a:extLst>
+              <a:ext uri="{FF2B5EF4-FFF2-40B4-BE49-F238E27FC236}">
+                <a16:creationId xmlns:a16="http://schemas.microsoft.com/office/drawing/2014/main" id="{16B2E32C-DF52-594A-5D8F-E28D9E1AFFCA}"/>
+              </a:ext>
+            </a:extLst>
+          </p:cNvPr>
+          <p:cNvPicPr>
+            <a:picLocks noChangeAspect="1"/>
+          </p:cNvPicPr>
+          <p:nvPr/>
+        </p:nvPicPr>
+        <p:blipFill>
+          <a:blip r:embed="rId3">
+            <a:extLst>
+              <a:ext uri="{28A0092B-C50C-407E-A947-70E740481C1C}">
+                <a14:useLocalDpi xmlns:a14="http://schemas.microsoft.com/office/drawing/2010/main" val="0"/>
+              </a:ext>
+            </a:extLst>
+          </a:blip>
+          <a:stretch>
+            <a:fillRect/>
+          </a:stretch>
+        </p:blipFill>
+        <p:spPr>
+          <a:xfrm>
+            <a:off x="4486299" y="5791200"/>
+            <a:ext cx="3219402" cy="685800"/>
+          </a:xfrm>
+          <a:prstGeom prst="rect">
+            <a:avLst/>
+          </a:prstGeom>
+        </p:spPr>
+      </p:pic>
+    </p:spTree>
+    <p:extLst>
+      <p:ext uri="{BB962C8B-B14F-4D97-AF65-F5344CB8AC3E}">
+        <p14:creationId xmlns:p14="http://schemas.microsoft.com/office/powerpoint/2010/main" val="1654209032"/>
+      </p:ext>
+    </p:extLst>
+  </p:cSld>
+  <p:clrMapOvr>
+    <a:masterClrMapping/>
+  </p:clrMapOvr>
+  <mc:AlternateContent xmlns:mc="http://schemas.openxmlformats.org/markup-compatibility/2006" xmlns:p159="http://schemas.microsoft.com/office/powerpoint/2015/09/main">
+    <mc:Choice Requires="p159">
+      <p:transition xmlns:p14="http://schemas.microsoft.com/office/powerpoint/2010/main" spd="slow" p14:dur="2000">
+        <p159:morph option="byObject"/>
+      </p:transition>
+    </mc:Choice>
+    <mc:Fallback xmlns="">
+      <p:transition spd="slow">
+        <p:fade/>
+      </p:transition>
+    </mc:Fallback>
+  </mc:AlternateContent>
+</p:sld>
+</file>
+
+<file path=ppt/slides/slide3.xml><?xml version="1.0" encoding="utf-8"?>
+<p:sld xmlns:a="http://schemas.openxmlformats.org/drawingml/2006/main" xmlns:r="http://schemas.openxmlformats.org/officeDocument/2006/relationships" xmlns:p="http://schemas.openxmlformats.org/presentationml/2006/main">
+  <p:cSld>
+    <p:spTree>
+      <p:nvGrpSpPr>
+        <p:cNvPr id="1" name=""/>
+        <p:cNvGrpSpPr/>
+        <p:nvPr/>
+      </p:nvGrpSpPr>
+      <p:grpSpPr>
+        <a:xfrm>
+          <a:off x="0" y="0"/>
+          <a:ext cx="0" cy="0"/>
+          <a:chOff x="0" y="0"/>
+          <a:chExt cx="0" cy="0"/>
+        </a:xfrm>
+      </p:grpSpPr>
+      <p:grpSp>
+        <p:nvGrpSpPr>
+          <p:cNvPr id="2" name="Agrupar 1">
+            <a:extLst>
+              <a:ext uri="{FF2B5EF4-FFF2-40B4-BE49-F238E27FC236}">
+                <a16:creationId xmlns:a16="http://schemas.microsoft.com/office/drawing/2014/main" id="{84B22FD0-C107-71F2-3863-3BCCF5D27EED}"/>
+              </a:ext>
+            </a:extLst>
+          </p:cNvPr>
+          <p:cNvGrpSpPr/>
+          <p:nvPr/>
+        </p:nvGrpSpPr>
+        <p:grpSpPr>
+          <a:xfrm>
+            <a:off x="1037000" y="1792191"/>
+            <a:ext cx="10118000" cy="3628007"/>
+            <a:chOff x="1037000" y="1792191"/>
+            <a:chExt cx="10118000" cy="3628007"/>
+          </a:xfrm>
+        </p:grpSpPr>
+        <p:pic>
+          <p:nvPicPr>
+            <p:cNvPr id="5" name="Google Shape;66;p2">
+              <a:extLst>
+                <a:ext uri="{FF2B5EF4-FFF2-40B4-BE49-F238E27FC236}">
+                  <a16:creationId xmlns:a16="http://schemas.microsoft.com/office/drawing/2014/main" id="{924EA9D4-4DEE-F7F7-A53A-70A78AFB59EB}"/>
+                </a:ext>
+              </a:extLst>
+            </p:cNvPr>
+            <p:cNvPicPr preferRelativeResize="0"/>
+            <p:nvPr/>
+          </p:nvPicPr>
+          <p:blipFill>
+            <a:blip r:embed="rId2">
+              <a:alphaModFix/>
+            </a:blip>
+            <a:stretch>
+              <a:fillRect/>
+            </a:stretch>
+          </p:blipFill>
+          <p:spPr>
+            <a:xfrm>
+              <a:off x="9397737" y="1792191"/>
+              <a:ext cx="1757128" cy="2653736"/>
+            </a:xfrm>
+            <a:prstGeom prst="rect">
+              <a:avLst/>
+            </a:prstGeom>
+            <a:solidFill>
+              <a:srgbClr val="FFFFFF">
+                <a:shade val="85000"/>
+              </a:srgbClr>
+            </a:solidFill>
+            <a:ln w="88900" cap="sq">
+              <a:solidFill>
+                <a:srgbClr val="FFFFFF"/>
+              </a:solidFill>
+              <a:miter lim="800000"/>
+            </a:ln>
+            <a:effectLst>
+              <a:outerShdw blurRad="55000" dist="18000" dir="5400000" algn="tl" rotWithShape="0">
+                <a:srgbClr val="000000">
+                  <a:alpha val="40000"/>
+                </a:srgbClr>
+              </a:outerShdw>
+            </a:effectLst>
+            <a:scene3d>
+              <a:camera prst="orthographicFront"/>
+              <a:lightRig rig="twoPt" dir="t">
+                <a:rot lat="0" lon="0" rev="7200000"/>
+              </a:lightRig>
+            </a:scene3d>
+            <a:sp3d>
+              <a:bevelT w="25400" h="19050"/>
+              <a:contourClr>
+                <a:srgbClr val="FFFFFF"/>
+              </a:contourClr>
+            </a:sp3d>
+          </p:spPr>
+        </p:pic>
+        <p:pic>
+          <p:nvPicPr>
+            <p:cNvPr id="6" name="Google Shape;67;p2">
+              <a:extLst>
+                <a:ext uri="{FF2B5EF4-FFF2-40B4-BE49-F238E27FC236}">
+                  <a16:creationId xmlns:a16="http://schemas.microsoft.com/office/drawing/2014/main" id="{1DE3959F-CCED-3584-D626-899604FB4DA5}"/>
+                </a:ext>
+              </a:extLst>
+            </p:cNvPr>
+            <p:cNvPicPr preferRelativeResize="0"/>
+            <p:nvPr/>
+          </p:nvPicPr>
+          <p:blipFill rotWithShape="1">
+            <a:blip r:embed="rId3">
+              <a:alphaModFix/>
+            </a:blip>
+            <a:srcRect l="2638" t="1996" r="3119" b="2492"/>
+            <a:stretch/>
+          </p:blipFill>
+          <p:spPr>
+            <a:xfrm>
+              <a:off x="1037000" y="1796429"/>
+              <a:ext cx="1757263" cy="2645260"/>
+            </a:xfrm>
+            <a:prstGeom prst="rect">
+              <a:avLst/>
+            </a:prstGeom>
+            <a:solidFill>
+              <a:srgbClr val="FFFFFF">
+                <a:shade val="85000"/>
+              </a:srgbClr>
+            </a:solidFill>
+            <a:ln w="88900" cap="sq">
+              <a:solidFill>
+                <a:srgbClr val="FFFFFF"/>
+              </a:solidFill>
+              <a:miter lim="800000"/>
+            </a:ln>
+            <a:effectLst>
+              <a:outerShdw blurRad="55000" dist="18000" dir="5400000" algn="tl" rotWithShape="0">
+                <a:srgbClr val="000000">
+                  <a:alpha val="40000"/>
+                </a:srgbClr>
+              </a:outerShdw>
+            </a:effectLst>
+            <a:scene3d>
+              <a:camera prst="orthographicFront"/>
+              <a:lightRig rig="twoPt" dir="t">
+                <a:rot lat="0" lon="0" rev="7200000"/>
+              </a:lightRig>
+            </a:scene3d>
+            <a:sp3d>
+              <a:bevelT w="25400" h="19050"/>
+              <a:contourClr>
+                <a:srgbClr val="FFFFFF"/>
+              </a:contourClr>
+            </a:sp3d>
+          </p:spPr>
+        </p:pic>
+        <p:pic>
+          <p:nvPicPr>
+            <p:cNvPr id="7" name="Google Shape;70;p2" descr="Tela de celular com foto de homem e texto&#10;&#10;O conteúdo gerado por IA pode estar incorreto.">
+              <a:extLst>
+                <a:ext uri="{FF2B5EF4-FFF2-40B4-BE49-F238E27FC236}">
+                  <a16:creationId xmlns:a16="http://schemas.microsoft.com/office/drawing/2014/main" id="{CF39C72C-2DBF-F854-95ED-FD66D706E77E}"/>
+                </a:ext>
+              </a:extLst>
+            </p:cNvPr>
+            <p:cNvPicPr preferRelativeResize="0"/>
+            <p:nvPr/>
+          </p:nvPicPr>
+          <p:blipFill rotWithShape="1">
+            <a:blip r:embed="rId4">
+              <a:alphaModFix/>
+            </a:blip>
+            <a:srcRect l="6795" t="4154" r="3429" b="2701"/>
+            <a:stretch/>
+          </p:blipFill>
+          <p:spPr>
+            <a:xfrm>
+              <a:off x="7307576" y="1804275"/>
+              <a:ext cx="1757156" cy="2629568"/>
+            </a:xfrm>
+            <a:prstGeom prst="rect">
+              <a:avLst/>
+            </a:prstGeom>
+            <a:solidFill>
+              <a:srgbClr val="FFFFFF">
+                <a:shade val="85000"/>
+              </a:srgbClr>
+            </a:solidFill>
+            <a:ln w="88900" cap="sq">
+              <a:solidFill>
+                <a:srgbClr val="FFFFFF"/>
+              </a:solidFill>
+              <a:miter lim="800000"/>
+            </a:ln>
+            <a:effectLst>
+              <a:outerShdw blurRad="55000" dist="18000" dir="5400000" algn="tl" rotWithShape="0">
+                <a:srgbClr val="000000">
+                  <a:alpha val="40000"/>
+                </a:srgbClr>
+              </a:outerShdw>
+            </a:effectLst>
+            <a:scene3d>
+              <a:camera prst="orthographicFront"/>
+              <a:lightRig rig="twoPt" dir="t">
+                <a:rot lat="0" lon="0" rev="7200000"/>
+              </a:lightRig>
+            </a:scene3d>
+            <a:sp3d>
+              <a:bevelT w="25400" h="19050"/>
+              <a:contourClr>
+                <a:srgbClr val="FFFFFF"/>
+              </a:contourClr>
+            </a:sp3d>
+          </p:spPr>
+        </p:pic>
+        <p:pic>
+          <p:nvPicPr>
+            <p:cNvPr id="9" name="Google Shape;72;p2" descr="Interface gráfica do usuário, Texto, Aplicativo&#10;&#10;O conteúdo gerado por IA pode estar incorreto.">
+              <a:extLst>
+                <a:ext uri="{FF2B5EF4-FFF2-40B4-BE49-F238E27FC236}">
+                  <a16:creationId xmlns:a16="http://schemas.microsoft.com/office/drawing/2014/main" id="{3CC89509-6FB9-8224-9965-6A83C6312067}"/>
+                </a:ext>
+              </a:extLst>
+            </p:cNvPr>
+            <p:cNvPicPr preferRelativeResize="0"/>
+            <p:nvPr/>
+          </p:nvPicPr>
+          <p:blipFill rotWithShape="1">
+            <a:blip r:embed="rId5">
+              <a:alphaModFix/>
+            </a:blip>
+            <a:srcRect l="4958" t="2436" r="2705" b="3490"/>
+            <a:stretch/>
+          </p:blipFill>
+          <p:spPr>
+            <a:xfrm>
+              <a:off x="3127266" y="1793453"/>
+              <a:ext cx="1757149" cy="2651210"/>
+            </a:xfrm>
+            <a:prstGeom prst="rect">
+              <a:avLst/>
+            </a:prstGeom>
+            <a:solidFill>
+              <a:srgbClr val="FFFFFF">
+                <a:shade val="85000"/>
+              </a:srgbClr>
+            </a:solidFill>
+            <a:ln w="88900" cap="sq">
+              <a:solidFill>
+                <a:srgbClr val="FFFFFF"/>
+              </a:solidFill>
+              <a:miter lim="800000"/>
+            </a:ln>
+            <a:effectLst>
+              <a:outerShdw blurRad="55000" dist="18000" dir="5400000" algn="tl" rotWithShape="0">
+                <a:srgbClr val="000000">
+                  <a:alpha val="40000"/>
+                </a:srgbClr>
+              </a:outerShdw>
+            </a:effectLst>
+            <a:scene3d>
+              <a:camera prst="orthographicFront"/>
+              <a:lightRig rig="twoPt" dir="t">
+                <a:rot lat="0" lon="0" rev="7200000"/>
+              </a:lightRig>
+            </a:scene3d>
+            <a:sp3d>
+              <a:bevelT w="25400" h="19050"/>
+              <a:contourClr>
+                <a:srgbClr val="FFFFFF"/>
+              </a:contourClr>
+            </a:sp3d>
+          </p:spPr>
+        </p:pic>
+        <p:pic>
+          <p:nvPicPr>
+            <p:cNvPr id="10" name="Google Shape;73;p2" descr="Interface gráfica do usuário, Texto, Aplicativo&#10;&#10;O conteúdo gerado por IA pode estar incorreto.">
+              <a:extLst>
+                <a:ext uri="{FF2B5EF4-FFF2-40B4-BE49-F238E27FC236}">
+                  <a16:creationId xmlns:a16="http://schemas.microsoft.com/office/drawing/2014/main" id="{D364BA3D-AA30-A1BF-1F23-1B54F5956C43}"/>
+                </a:ext>
+              </a:extLst>
+            </p:cNvPr>
+            <p:cNvPicPr preferRelativeResize="0"/>
+            <p:nvPr/>
+          </p:nvPicPr>
+          <p:blipFill rotWithShape="1">
+            <a:blip r:embed="rId6">
+              <a:alphaModFix/>
+            </a:blip>
+            <a:srcRect l="5726" t="1116" r="2056" b="2590"/>
+            <a:stretch/>
+          </p:blipFill>
+          <p:spPr>
+            <a:xfrm>
+              <a:off x="5217417" y="1795392"/>
+              <a:ext cx="1757156" cy="2647333"/>
+            </a:xfrm>
+            <a:prstGeom prst="rect">
+              <a:avLst/>
+            </a:prstGeom>
+            <a:solidFill>
+              <a:srgbClr val="FFFFFF">
+                <a:shade val="85000"/>
+              </a:srgbClr>
+            </a:solidFill>
+            <a:ln w="88900" cap="sq">
+              <a:solidFill>
+                <a:srgbClr val="FFFFFF"/>
+              </a:solidFill>
+              <a:miter lim="800000"/>
+            </a:ln>
+            <a:effectLst>
+              <a:outerShdw blurRad="55000" dist="18000" dir="5400000" algn="tl" rotWithShape="0">
+                <a:srgbClr val="000000">
+                  <a:alpha val="40000"/>
+                </a:srgbClr>
+              </a:outerShdw>
+            </a:effectLst>
+            <a:scene3d>
+              <a:camera prst="orthographicFront"/>
+              <a:lightRig rig="twoPt" dir="t">
+                <a:rot lat="0" lon="0" rev="7200000"/>
+              </a:lightRig>
+            </a:scene3d>
+            <a:sp3d>
+              <a:bevelT w="25400" h="19050"/>
+              <a:contourClr>
+                <a:srgbClr val="FFFFFF"/>
+              </a:contourClr>
+            </a:sp3d>
+          </p:spPr>
+        </p:pic>
+        <p:sp>
+          <p:nvSpPr>
+            <p:cNvPr id="11" name="Google Shape;74;p2">
+              <a:extLst>
+                <a:ext uri="{FF2B5EF4-FFF2-40B4-BE49-F238E27FC236}">
+                  <a16:creationId xmlns:a16="http://schemas.microsoft.com/office/drawing/2014/main" id="{BFF0B7DD-BB0C-57B3-54A0-0F66A780440C}"/>
+                </a:ext>
+              </a:extLst>
+            </p:cNvPr>
+            <p:cNvSpPr txBox="1"/>
+            <p:nvPr/>
+          </p:nvSpPr>
+          <p:spPr>
+            <a:xfrm>
+              <a:off x="7307576" y="4600389"/>
+              <a:ext cx="1757263" cy="819809"/>
+            </a:xfrm>
+            <a:prstGeom prst="rect">
+              <a:avLst/>
+            </a:prstGeom>
+            <a:noFill/>
+            <a:ln w="9525" cap="flat" cmpd="sng">
+              <a:noFill/>
+              <a:prstDash val="solid"/>
+              <a:round/>
+              <a:headEnd type="none" w="sm" len="sm"/>
+              <a:tailEnd type="none" w="sm" len="sm"/>
+            </a:ln>
+          </p:spPr>
+          <p:txBody>
+            <a:bodyPr spcFirstLastPara="1" wrap="square" lIns="85900" tIns="85900" rIns="85900" bIns="85900" anchor="t" anchorCtr="0">
+              <a:spAutoFit/>
+            </a:bodyPr>
+            <a:lstStyle/>
+            <a:p>
+              <a:pPr marL="0" lvl="0" indent="0" algn="ctr" rtl="0">
+                <a:spcBef>
+                  <a:spcPts val="0"/>
+                </a:spcBef>
+                <a:spcAft>
+                  <a:spcPts val="0"/>
+                </a:spcAft>
+                <a:buNone/>
+              </a:pPr>
+              <a:r>
+                <a:rPr lang="en-US" sz="1400" b="1">
+                  <a:solidFill>
+                    <a:schemeClr val="tx1">
+                      <a:lumMod val="75000"/>
+                      <a:lumOff val="25000"/>
+                    </a:schemeClr>
+                  </a:solidFill>
+                  <a:latin typeface="Ubuntu" panose="020B0504030602030204" pitchFamily="34" charset="0"/>
+                </a:rPr>
+                <a:t>Engenheiro de Hardware e Firmware (ESP32)</a:t>
+              </a:r>
+              <a:endParaRPr sz="1400">
+                <a:solidFill>
+                  <a:schemeClr val="tx1">
+                    <a:lumMod val="75000"/>
+                    <a:lumOff val="25000"/>
+                  </a:schemeClr>
+                </a:solidFill>
+                <a:latin typeface="Ubuntu" panose="020B0504030602030204" pitchFamily="34" charset="0"/>
+              </a:endParaRPr>
+            </a:p>
+          </p:txBody>
+        </p:sp>
+        <p:sp>
+          <p:nvSpPr>
+            <p:cNvPr id="12" name="Google Shape;75;p2">
+              <a:extLst>
+                <a:ext uri="{FF2B5EF4-FFF2-40B4-BE49-F238E27FC236}">
+                  <a16:creationId xmlns:a16="http://schemas.microsoft.com/office/drawing/2014/main" id="{9D7F622B-F0B5-30BD-BCDD-66FA00B0A8E7}"/>
+                </a:ext>
+              </a:extLst>
+            </p:cNvPr>
+            <p:cNvSpPr txBox="1"/>
+            <p:nvPr/>
+          </p:nvSpPr>
+          <p:spPr>
+            <a:xfrm>
+              <a:off x="9397737" y="4600386"/>
+              <a:ext cx="1757263" cy="604365"/>
+            </a:xfrm>
+            <a:prstGeom prst="rect">
+              <a:avLst/>
+            </a:prstGeom>
+            <a:noFill/>
+            <a:ln w="9525" cap="flat" cmpd="sng">
+              <a:noFill/>
+              <a:prstDash val="solid"/>
+              <a:round/>
+              <a:headEnd type="none" w="sm" len="sm"/>
+              <a:tailEnd type="none" w="sm" len="sm"/>
+            </a:ln>
+          </p:spPr>
+          <p:txBody>
+            <a:bodyPr spcFirstLastPara="1" wrap="square" lIns="85900" tIns="85900" rIns="85900" bIns="85900" anchor="t" anchorCtr="0">
+              <a:spAutoFit/>
+            </a:bodyPr>
+            <a:lstStyle/>
+            <a:p>
+              <a:pPr marL="0" lvl="0" indent="0" algn="ctr" rtl="0">
+                <a:spcBef>
+                  <a:spcPts val="0"/>
+                </a:spcBef>
+                <a:spcAft>
+                  <a:spcPts val="0"/>
+                </a:spcAft>
+                <a:buNone/>
+              </a:pPr>
+              <a:r>
+                <a:rPr lang="en-US" sz="1400" b="1" dirty="0" err="1">
+                  <a:solidFill>
+                    <a:schemeClr val="tx1">
+                      <a:lumMod val="75000"/>
+                      <a:lumOff val="25000"/>
+                    </a:schemeClr>
+                  </a:solidFill>
+                  <a:latin typeface="Ubuntu" panose="020B0504030602030204" pitchFamily="34" charset="0"/>
+                </a:rPr>
+                <a:t>Engenheiro</a:t>
+              </a:r>
+              <a:r>
+                <a:rPr lang="en-US" sz="1400" b="1" dirty="0">
+                  <a:solidFill>
+                    <a:schemeClr val="tx1">
+                      <a:lumMod val="75000"/>
+                      <a:lumOff val="25000"/>
+                    </a:schemeClr>
+                  </a:solidFill>
+                  <a:latin typeface="Ubuntu" panose="020B0504030602030204" pitchFamily="34" charset="0"/>
+                </a:rPr>
+                <a:t> de Kernel</a:t>
+              </a:r>
+              <a:endParaRPr sz="1400" dirty="0">
+                <a:solidFill>
+                  <a:schemeClr val="tx1">
+                    <a:lumMod val="75000"/>
+                    <a:lumOff val="25000"/>
+                  </a:schemeClr>
+                </a:solidFill>
+                <a:latin typeface="Ubuntu" panose="020B0504030602030204" pitchFamily="34" charset="0"/>
+              </a:endParaRPr>
+            </a:p>
+          </p:txBody>
+        </p:sp>
+        <p:sp>
+          <p:nvSpPr>
+            <p:cNvPr id="13" name="Google Shape;76;p2">
+              <a:extLst>
+                <a:ext uri="{FF2B5EF4-FFF2-40B4-BE49-F238E27FC236}">
+                  <a16:creationId xmlns:a16="http://schemas.microsoft.com/office/drawing/2014/main" id="{EA3A6042-FB45-EF7B-04AA-8B29651B7BE0}"/>
+                </a:ext>
+              </a:extLst>
+            </p:cNvPr>
+            <p:cNvSpPr txBox="1"/>
+            <p:nvPr/>
+          </p:nvSpPr>
+          <p:spPr>
+            <a:xfrm>
+              <a:off x="1052117" y="4579387"/>
+              <a:ext cx="1742136" cy="819809"/>
+            </a:xfrm>
+            <a:prstGeom prst="rect">
+              <a:avLst/>
+            </a:prstGeom>
+            <a:noFill/>
+            <a:ln w="9525" cap="flat" cmpd="sng">
+              <a:noFill/>
+              <a:prstDash val="solid"/>
+              <a:round/>
+              <a:headEnd type="none" w="sm" len="sm"/>
+              <a:tailEnd type="none" w="sm" len="sm"/>
+            </a:ln>
+          </p:spPr>
+          <p:txBody>
+            <a:bodyPr spcFirstLastPara="1" wrap="square" lIns="85900" tIns="85900" rIns="85900" bIns="85900" anchor="t" anchorCtr="0">
+              <a:spAutoFit/>
+            </a:bodyPr>
+            <a:lstStyle/>
+            <a:p>
+              <a:pPr marL="0" lvl="0" indent="0" algn="ctr" rtl="0">
+                <a:spcBef>
+                  <a:spcPts val="0"/>
+                </a:spcBef>
+                <a:spcAft>
+                  <a:spcPts val="0"/>
+                </a:spcAft>
+                <a:buNone/>
+              </a:pPr>
+              <a:r>
+                <a:rPr lang="en-US" sz="1400" b="1" dirty="0" err="1">
+                  <a:solidFill>
+                    <a:schemeClr val="tx1">
+                      <a:lumMod val="75000"/>
+                      <a:lumOff val="25000"/>
+                    </a:schemeClr>
+                  </a:solidFill>
+                  <a:latin typeface="Ubuntu" panose="020B0504030602030204" pitchFamily="34" charset="0"/>
+                </a:rPr>
+                <a:t>Engenheiro</a:t>
+              </a:r>
+              <a:r>
+                <a:rPr lang="en-US" sz="1400" b="1" dirty="0">
+                  <a:solidFill>
+                    <a:schemeClr val="tx1">
+                      <a:lumMod val="75000"/>
+                      <a:lumOff val="25000"/>
+                    </a:schemeClr>
+                  </a:solidFill>
+                  <a:latin typeface="Ubuntu" panose="020B0504030602030204" pitchFamily="34" charset="0"/>
+                </a:rPr>
+                <a:t> de HAL (</a:t>
+              </a:r>
+              <a:r>
+                <a:rPr lang="en-US" sz="1400" b="1" dirty="0" err="1">
+                  <a:solidFill>
+                    <a:schemeClr val="tx1">
+                      <a:lumMod val="75000"/>
+                      <a:lumOff val="25000"/>
+                    </a:schemeClr>
+                  </a:solidFill>
+                  <a:latin typeface="Ubuntu" panose="020B0504030602030204" pitchFamily="34" charset="0"/>
+                </a:rPr>
+                <a:t>Implementação</a:t>
+              </a:r>
+              <a:r>
+                <a:rPr lang="en-US" sz="1400" b="1" dirty="0">
+                  <a:solidFill>
+                    <a:schemeClr val="tx1">
+                      <a:lumMod val="75000"/>
+                      <a:lumOff val="25000"/>
+                    </a:schemeClr>
+                  </a:solidFill>
+                  <a:latin typeface="Ubuntu" panose="020B0504030602030204" pitchFamily="34" charset="0"/>
+                </a:rPr>
+                <a:t>)</a:t>
+              </a:r>
+              <a:endParaRPr sz="1400" dirty="0">
+                <a:solidFill>
+                  <a:schemeClr val="tx1">
+                    <a:lumMod val="75000"/>
+                    <a:lumOff val="25000"/>
+                  </a:schemeClr>
+                </a:solidFill>
+                <a:latin typeface="Ubuntu" panose="020B0504030602030204" pitchFamily="34" charset="0"/>
+              </a:endParaRPr>
+            </a:p>
+          </p:txBody>
+        </p:sp>
+        <p:sp>
+          <p:nvSpPr>
+            <p:cNvPr id="14" name="Google Shape;77;p2">
+              <a:extLst>
+                <a:ext uri="{FF2B5EF4-FFF2-40B4-BE49-F238E27FC236}">
+                  <a16:creationId xmlns:a16="http://schemas.microsoft.com/office/drawing/2014/main" id="{5379B1CB-A574-AA79-9CF3-C99CB4FDB3A5}"/>
+                </a:ext>
+              </a:extLst>
+            </p:cNvPr>
+            <p:cNvSpPr txBox="1"/>
+            <p:nvPr/>
+          </p:nvSpPr>
+          <p:spPr>
+            <a:xfrm>
+              <a:off x="5239985" y="4579387"/>
+              <a:ext cx="1757263" cy="819809"/>
+            </a:xfrm>
+            <a:prstGeom prst="rect">
+              <a:avLst/>
+            </a:prstGeom>
+            <a:noFill/>
+            <a:ln w="9525" cap="flat" cmpd="sng">
+              <a:noFill/>
+              <a:prstDash val="solid"/>
+              <a:round/>
+              <a:headEnd type="none" w="sm" len="sm"/>
+              <a:tailEnd type="none" w="sm" len="sm"/>
+            </a:ln>
+          </p:spPr>
+          <p:txBody>
+            <a:bodyPr spcFirstLastPara="1" wrap="square" lIns="85900" tIns="85900" rIns="85900" bIns="85900" anchor="t" anchorCtr="0">
+              <a:spAutoFit/>
+            </a:bodyPr>
+            <a:lstStyle/>
+            <a:p>
+              <a:pPr marL="0" lvl="0" indent="0" algn="ctr" rtl="0">
+                <a:spcBef>
+                  <a:spcPts val="0"/>
+                </a:spcBef>
+                <a:spcAft>
+                  <a:spcPts val="0"/>
+                </a:spcAft>
+                <a:buNone/>
+              </a:pPr>
+              <a:r>
+                <a:rPr lang="en-US" sz="1400" b="1" dirty="0" err="1">
+                  <a:solidFill>
+                    <a:schemeClr val="tx1">
+                      <a:lumMod val="75000"/>
+                      <a:lumOff val="25000"/>
+                    </a:schemeClr>
+                  </a:solidFill>
+                  <a:latin typeface="Ubuntu" panose="020B0504030602030204" pitchFamily="34" charset="0"/>
+                </a:rPr>
+                <a:t>Engenheiro</a:t>
+              </a:r>
+              <a:r>
+                <a:rPr lang="en-US" sz="1400" b="1" dirty="0">
+                  <a:solidFill>
+                    <a:schemeClr val="tx1">
+                      <a:lumMod val="75000"/>
+                      <a:lumOff val="25000"/>
+                    </a:schemeClr>
+                  </a:solidFill>
+                  <a:latin typeface="Ubuntu" panose="020B0504030602030204" pitchFamily="34" charset="0"/>
+                </a:rPr>
+                <a:t> de Framework e Pesquisa</a:t>
+              </a:r>
+              <a:endParaRPr sz="1400" dirty="0">
+                <a:solidFill>
+                  <a:schemeClr val="tx1">
+                    <a:lumMod val="75000"/>
+                    <a:lumOff val="25000"/>
+                  </a:schemeClr>
+                </a:solidFill>
+                <a:latin typeface="Ubuntu" panose="020B0504030602030204" pitchFamily="34" charset="0"/>
+              </a:endParaRPr>
+            </a:p>
+          </p:txBody>
+        </p:sp>
+        <p:sp>
+          <p:nvSpPr>
+            <p:cNvPr id="15" name="Google Shape;78;p2">
+              <a:extLst>
+                <a:ext uri="{FF2B5EF4-FFF2-40B4-BE49-F238E27FC236}">
+                  <a16:creationId xmlns:a16="http://schemas.microsoft.com/office/drawing/2014/main" id="{119831CE-0B20-AA59-0C84-7F844EFF7A86}"/>
+                </a:ext>
+              </a:extLst>
+            </p:cNvPr>
+            <p:cNvSpPr txBox="1"/>
+            <p:nvPr/>
+          </p:nvSpPr>
+          <p:spPr>
+            <a:xfrm>
+              <a:off x="3127152" y="4579387"/>
+              <a:ext cx="1757263" cy="819809"/>
+            </a:xfrm>
+            <a:prstGeom prst="rect">
+              <a:avLst/>
+            </a:prstGeom>
+            <a:noFill/>
+            <a:ln w="9525" cap="flat" cmpd="sng">
+              <a:noFill/>
+              <a:prstDash val="solid"/>
+              <a:round/>
+              <a:headEnd type="none" w="sm" len="sm"/>
+              <a:tailEnd type="none" w="sm" len="sm"/>
+            </a:ln>
+          </p:spPr>
+          <p:txBody>
+            <a:bodyPr spcFirstLastPara="1" wrap="square" lIns="85900" tIns="85900" rIns="85900" bIns="85900" anchor="t" anchorCtr="0">
+              <a:spAutoFit/>
+            </a:bodyPr>
+            <a:lstStyle/>
+            <a:p>
+              <a:pPr marL="0" lvl="0" indent="0" algn="ctr" rtl="0">
+                <a:spcBef>
+                  <a:spcPts val="0"/>
+                </a:spcBef>
+                <a:spcAft>
+                  <a:spcPts val="0"/>
+                </a:spcAft>
+                <a:buNone/>
+              </a:pPr>
+              <a:r>
+                <a:rPr lang="en-US" sz="1400" b="1">
+                  <a:solidFill>
+                    <a:schemeClr val="tx1">
+                      <a:lumMod val="75000"/>
+                      <a:lumOff val="25000"/>
+                    </a:schemeClr>
+                  </a:solidFill>
+                  <a:latin typeface="Ubuntu" panose="020B0504030602030204" pitchFamily="34" charset="0"/>
+                </a:rPr>
+                <a:t>Engenheiro de Aplicação e Integração</a:t>
+              </a:r>
+              <a:endParaRPr sz="1400">
+                <a:solidFill>
+                  <a:schemeClr val="tx1">
+                    <a:lumMod val="75000"/>
+                    <a:lumOff val="25000"/>
+                  </a:schemeClr>
+                </a:solidFill>
+                <a:latin typeface="Ubuntu" panose="020B0504030602030204" pitchFamily="34" charset="0"/>
+              </a:endParaRPr>
+            </a:p>
+          </p:txBody>
+        </p:sp>
+      </p:grpSp>
+      <p:sp>
+        <p:nvSpPr>
+          <p:cNvPr id="17" name="Retângulo 16">
+            <a:extLst>
+              <a:ext uri="{FF2B5EF4-FFF2-40B4-BE49-F238E27FC236}">
+                <a16:creationId xmlns:a16="http://schemas.microsoft.com/office/drawing/2014/main" id="{2F27116E-5F81-BCBF-E044-4610C3639D85}"/>
+              </a:ext>
+            </a:extLst>
+          </p:cNvPr>
+          <p:cNvSpPr/>
+          <p:nvPr/>
+        </p:nvSpPr>
+        <p:spPr>
+          <a:xfrm>
+            <a:off x="-159658" y="1186499"/>
+            <a:ext cx="6094113" cy="92335"/>
+          </a:xfrm>
+          <a:prstGeom prst="rect">
+            <a:avLst/>
+          </a:prstGeom>
+          <a:solidFill>
+            <a:srgbClr val="C00000"/>
+          </a:solidFill>
+          <a:ln>
+            <a:noFill/>
+          </a:ln>
+        </p:spPr>
+        <p:style>
+          <a:lnRef idx="2">
+            <a:schemeClr val="accent1">
+              <a:shade val="15000"/>
+            </a:schemeClr>
+          </a:lnRef>
+          <a:fillRef idx="1">
+            <a:schemeClr val="accent1"/>
+          </a:fillRef>
+          <a:effectRef idx="0">
+            <a:schemeClr val="accent1"/>
+          </a:effectRef>
+          <a:fontRef idx="minor">
+            <a:schemeClr val="lt1"/>
+          </a:fontRef>
+        </p:style>
+        <p:txBody>
+          <a:bodyPr rtlCol="0" anchor="ctr"/>
+          <a:lstStyle/>
+          <a:p>
+            <a:pPr algn="ctr"/>
+            <a:endParaRPr lang="en-US"/>
+          </a:p>
+        </p:txBody>
+      </p:sp>
+      <p:sp>
+        <p:nvSpPr>
+          <p:cNvPr id="18" name="CaixaDeTexto 17">
+            <a:extLst>
+              <a:ext uri="{FF2B5EF4-FFF2-40B4-BE49-F238E27FC236}">
+                <a16:creationId xmlns:a16="http://schemas.microsoft.com/office/drawing/2014/main" id="{9745935D-ED5F-BB06-A4EA-6B41FBF934BF}"/>
+              </a:ext>
+            </a:extLst>
+          </p:cNvPr>
+          <p:cNvSpPr txBox="1"/>
+          <p:nvPr/>
+        </p:nvSpPr>
+        <p:spPr>
+          <a:xfrm>
+            <a:off x="753173" y="396593"/>
+            <a:ext cx="6221400" cy="707886"/>
+          </a:xfrm>
+          <a:prstGeom prst="rect">
+            <a:avLst/>
+          </a:prstGeom>
+          <a:noFill/>
+        </p:spPr>
+        <p:txBody>
+          <a:bodyPr wrap="square" rtlCol="0">
+            <a:spAutoFit/>
+          </a:bodyPr>
+          <a:lstStyle/>
+          <a:p>
+            <a:r>
+              <a:rPr lang="pt-BR" sz="4000" b="1" noProof="0" dirty="0">
+                <a:solidFill>
+                  <a:schemeClr val="tx1">
+                    <a:lumMod val="75000"/>
+                    <a:lumOff val="25000"/>
+                  </a:schemeClr>
+                </a:solidFill>
+                <a:latin typeface="Ubuntu Medium" panose="020B0604030602030204" pitchFamily="34" charset="0"/>
+              </a:rPr>
+              <a:t>Integrantes | Equipe 5</a:t>
+            </a:r>
+          </a:p>
+        </p:txBody>
+      </p:sp>
     </p:spTree>
     <p:extLst>
       <p:ext uri="{BB962C8B-B14F-4D97-AF65-F5344CB8AC3E}">
         <p14:creationId xmlns:p14="http://schemas.microsoft.com/office/powerpoint/2010/main" val="2554293162"/>
+      </p:ext>
+    </p:extLst>
+  </p:cSld>
+  <p:clrMapOvr>
+    <a:masterClrMapping/>
+  </p:clrMapOvr>
+  <mc:AlternateContent xmlns:mc="http://schemas.openxmlformats.org/markup-compatibility/2006" xmlns:p14="http://schemas.microsoft.com/office/powerpoint/2010/main">
+    <mc:Choice Requires="p14">
+      <p:transition spd="med" p14:dur="700">
+        <p:fade/>
+      </p:transition>
+    </mc:Choice>
+    <mc:Fallback xmlns="">
+      <p:transition spd="med">
+        <p:fade/>
+      </p:transition>
+    </mc:Fallback>
+  </mc:AlternateContent>
+</p:sld>
+</file>
+
+<file path=ppt/slides/slide4.xml><?xml version="1.0" encoding="utf-8"?>
+<p:sld xmlns:a="http://schemas.openxmlformats.org/drawingml/2006/main" xmlns:r="http://schemas.openxmlformats.org/officeDocument/2006/relationships" xmlns:p="http://schemas.openxmlformats.org/presentationml/2006/main">
+  <p:cSld>
+    <p:spTree>
+      <p:nvGrpSpPr>
+        <p:cNvPr id="1" name=""/>
+        <p:cNvGrpSpPr/>
+        <p:nvPr/>
+      </p:nvGrpSpPr>
+      <p:grpSpPr>
+        <a:xfrm>
+          <a:off x="0" y="0"/>
+          <a:ext cx="0" cy="0"/>
+          <a:chOff x="0" y="0"/>
+          <a:chExt cx="0" cy="0"/>
+        </a:xfrm>
+      </p:grpSpPr>
+    </p:spTree>
+    <p:extLst>
+      <p:ext uri="{BB962C8B-B14F-4D97-AF65-F5344CB8AC3E}">
+        <p14:creationId xmlns:p14="http://schemas.microsoft.com/office/powerpoint/2010/main" val="2872158272"/>
       </p:ext>
     </p:extLst>
   </p:cSld>

</xml_diff>